<commit_message>
made changes to data
</commit_message>
<xml_diff>
--- a/deliverables/UG15_Campaign_Readout.pptx
+++ b/deliverables/UG15_Campaign_Readout.pptx
@@ -145,7 +145,7 @@
           <c:spPr>
             <a:ln w="34925">
               <a:solidFill>
-                <a:srgbClr val="2251FF"/>
+                <a:srgbClr val="DA291C"/>
               </a:solidFill>
             </a:ln>
           </c:spPr>
@@ -537,7 +537,7 @@
             <c:idx val="0"/>
             <c:spPr>
               <a:solidFill>
-                <a:srgbClr val="051C2C"/>
+                <a:srgbClr val="000000"/>
               </a:solidFill>
             </c:spPr>
           </c:dPt>
@@ -553,7 +553,7 @@
             <c:idx val="2"/>
             <c:spPr>
               <a:solidFill>
-                <a:srgbClr val="051C2C"/>
+                <a:srgbClr val="000000"/>
               </a:solidFill>
             </c:spPr>
           </c:dPt>
@@ -561,7 +561,7 @@
             <c:idx val="3"/>
             <c:spPr>
               <a:solidFill>
-                <a:srgbClr val="2251FF"/>
+                <a:srgbClr val="DA291C"/>
               </a:solidFill>
             </c:spPr>
           </c:dPt>
@@ -577,7 +577,7 @@
             <c:idx val="5"/>
             <c:spPr>
               <a:solidFill>
-                <a:srgbClr val="2251FF"/>
+                <a:srgbClr val="DA291C"/>
               </a:solidFill>
             </c:spPr>
           </c:dPt>
@@ -766,7 +766,7 @@
             <c:idx val="0"/>
             <c:spPr>
               <a:solidFill>
-                <a:srgbClr val="2251FF"/>
+                <a:srgbClr val="DA291C"/>
               </a:solidFill>
               <a:ln w="25400">
                 <a:solidFill>
@@ -925,7 +925,7 @@
           </c:tx>
           <c:spPr>
             <a:solidFill>
-              <a:srgbClr val="2251FF"/>
+              <a:srgbClr val="DA291C"/>
             </a:solidFill>
           </c:spPr>
           <c:cat>
@@ -1106,7 +1106,7 @@
             <c:idx val="0"/>
             <c:spPr>
               <a:solidFill>
-                <a:srgbClr val="2251FF"/>
+                <a:srgbClr val="DA291C"/>
               </a:solidFill>
             </c:spPr>
           </c:dPt>
@@ -1114,7 +1114,7 @@
             <c:idx val="1"/>
             <c:spPr>
               <a:solidFill>
-                <a:srgbClr val="2251FF"/>
+                <a:srgbClr val="DA291C"/>
               </a:solidFill>
             </c:spPr>
           </c:dPt>
@@ -1122,7 +1122,7 @@
             <c:idx val="2"/>
             <c:spPr>
               <a:solidFill>
-                <a:srgbClr val="00A9F4"/>
+                <a:srgbClr val="1F7A4D"/>
               </a:solidFill>
             </c:spPr>
           </c:dPt>
@@ -1292,7 +1292,7 @@
             <c:idx val="0"/>
             <c:spPr>
               <a:solidFill>
-                <a:srgbClr val="2251FF"/>
+                <a:srgbClr val="DA291C"/>
               </a:solidFill>
             </c:spPr>
           </c:dPt>
@@ -1300,7 +1300,7 @@
             <c:idx val="1"/>
             <c:spPr>
               <a:solidFill>
-                <a:srgbClr val="2251FF"/>
+                <a:srgbClr val="DA291C"/>
               </a:solidFill>
             </c:spPr>
           </c:dPt>
@@ -1308,7 +1308,7 @@
             <c:idx val="2"/>
             <c:spPr>
               <a:solidFill>
-                <a:srgbClr val="051C2C"/>
+                <a:srgbClr val="000000"/>
               </a:solidFill>
             </c:spPr>
           </c:dPt>
@@ -1494,7 +1494,7 @@
             <c:idx val="2"/>
             <c:spPr>
               <a:solidFill>
-                <a:srgbClr val="2251FF"/>
+                <a:srgbClr val="DA291C"/>
               </a:solidFill>
             </c:spPr>
           </c:dPt>
@@ -1502,7 +1502,7 @@
             <c:idx val="3"/>
             <c:spPr>
               <a:solidFill>
-                <a:srgbClr val="2251FF"/>
+                <a:srgbClr val="DA291C"/>
               </a:solidFill>
             </c:spPr>
           </c:dPt>
@@ -1510,7 +1510,7 @@
             <c:idx val="4"/>
             <c:spPr>
               <a:solidFill>
-                <a:srgbClr val="2251FF"/>
+                <a:srgbClr val="DA291C"/>
               </a:solidFill>
             </c:spPr>
           </c:dPt>
@@ -1691,7 +1691,7 @@
           <c:spPr>
             <a:ln w="34925">
               <a:solidFill>
-                <a:srgbClr val="2251FF"/>
+                <a:srgbClr val="DA291C"/>
               </a:solidFill>
             </a:ln>
           </c:spPr>
@@ -1707,7 +1707,7 @@
                 <a:pPr>
                   <a:defRPr sz="1000" b="0">
                     <a:solidFill>
-                      <a:srgbClr val="2251FF"/>
+                      <a:srgbClr val="DA291C"/>
                     </a:solidFill>
                   </a:defRPr>
                 </a:pPr>
@@ -4977,7 +4977,7 @@
             <a:avLst/>
           </a:prstGeom>
           <a:solidFill>
-            <a:srgbClr val="051C2C"/>
+            <a:srgbClr val="000000"/>
           </a:solidFill>
           <a:ln>
             <a:noFill/>
@@ -5067,7 +5067,7 @@
             <a:r>
               <a:rPr sz="2400" b="0" i="0">
                 <a:solidFill>
-                  <a:srgbClr val="00A9F4"/>
+                  <a:srgbClr val="DA291C"/>
                 </a:solidFill>
                 <a:latin typeface="Georgia"/>
               </a:rPr>
@@ -5166,6 +5166,30 @@
           </a:p>
         </p:txBody>
       </p:sp>
+      <p:pic>
+        <p:nvPicPr>
+          <p:cNvPr id="7" name="Picture 6" descr="salomon_wordmark_white.png"/>
+          <p:cNvPicPr>
+            <a:picLocks noChangeAspect="1"/>
+          </p:cNvPicPr>
+          <p:nvPr/>
+        </p:nvPicPr>
+        <p:blipFill>
+          <a:blip r:embed="rId2"/>
+          <a:stretch>
+            <a:fillRect/>
+          </a:stretch>
+        </p:blipFill>
+        <p:spPr>
+          <a:xfrm>
+            <a:off x="822960" y="900000"/>
+            <a:ext cx="2560320" cy="293370"/>
+          </a:xfrm>
+          <a:prstGeom prst="rect">
+            <a:avLst/>
+          </a:prstGeom>
+        </p:spPr>
+      </p:pic>
     </p:spTree>
   </p:cSld>
   <p:clrMapOvr>
@@ -5245,7 +5269,7 @@
             <a:r>
               <a:rPr sz="2300" b="0" i="0">
                 <a:solidFill>
-                  <a:srgbClr val="051C2C"/>
+                  <a:srgbClr val="000000"/>
                 </a:solidFill>
                 <a:latin typeface="Georgia"/>
               </a:rPr>
@@ -5512,6 +5536,30 @@
           </a:p>
         </p:txBody>
       </p:sp>
+      <p:pic>
+        <p:nvPicPr>
+          <p:cNvPr id="9" name="Picture 8" descr="salomon_wordmark_black.png"/>
+          <p:cNvPicPr>
+            <a:picLocks noChangeAspect="1"/>
+          </p:cNvPicPr>
+          <p:nvPr/>
+        </p:nvPicPr>
+        <p:blipFill>
+          <a:blip r:embed="rId3"/>
+          <a:stretch>
+            <a:fillRect/>
+          </a:stretch>
+        </p:blipFill>
+        <p:spPr>
+          <a:xfrm>
+            <a:off x="10698480" y="292608"/>
+            <a:ext cx="960120" cy="110013"/>
+          </a:xfrm>
+          <a:prstGeom prst="rect">
+            <a:avLst/>
+          </a:prstGeom>
+        </p:spPr>
+      </p:pic>
     </p:spTree>
   </p:cSld>
   <p:clrMapOvr>
@@ -5591,7 +5639,7 @@
             <a:r>
               <a:rPr sz="2300" b="0" i="0">
                 <a:solidFill>
-                  <a:srgbClr val="051C2C"/>
+                  <a:srgbClr val="000000"/>
                 </a:solidFill>
                 <a:latin typeface="Georgia"/>
               </a:rPr>
@@ -5644,7 +5692,7 @@
                   </a:txBody>
                   <a:tcPr marL="73152" marR="36576" anchor="ctr">
                     <a:solidFill>
-                      <a:srgbClr val="051C2C"/>
+                      <a:srgbClr val="000000"/>
                     </a:solidFill>
                   </a:tcPr>
                 </a:tc>
@@ -5666,7 +5714,7 @@
                   </a:txBody>
                   <a:tcPr marL="73152" marR="36576" anchor="ctr">
                     <a:solidFill>
-                      <a:srgbClr val="051C2C"/>
+                      <a:srgbClr val="000000"/>
                     </a:solidFill>
                   </a:tcPr>
                 </a:tc>
@@ -5688,7 +5736,7 @@
                   </a:txBody>
                   <a:tcPr marL="73152" marR="36576" anchor="ctr">
                     <a:solidFill>
-                      <a:srgbClr val="051C2C"/>
+                      <a:srgbClr val="000000"/>
                     </a:solidFill>
                   </a:tcPr>
                 </a:tc>
@@ -5710,7 +5758,7 @@
                   </a:txBody>
                   <a:tcPr marL="73152" marR="36576" anchor="ctr">
                     <a:solidFill>
-                      <a:srgbClr val="051C2C"/>
+                      <a:srgbClr val="000000"/>
                     </a:solidFill>
                   </a:tcPr>
                 </a:tc>
@@ -5732,7 +5780,7 @@
                   </a:txBody>
                   <a:tcPr marL="73152" marR="36576" anchor="ctr">
                     <a:solidFill>
-                      <a:srgbClr val="051C2C"/>
+                      <a:srgbClr val="000000"/>
                     </a:solidFill>
                   </a:tcPr>
                 </a:tc>
@@ -6819,6 +6867,30 @@
           </a:p>
         </p:txBody>
       </p:sp>
+      <p:pic>
+        <p:nvPicPr>
+          <p:cNvPr id="7" name="Picture 6" descr="salomon_wordmark_black.png"/>
+          <p:cNvPicPr>
+            <a:picLocks noChangeAspect="1"/>
+          </p:cNvPicPr>
+          <p:nvPr/>
+        </p:nvPicPr>
+        <p:blipFill>
+          <a:blip r:embed="rId2"/>
+          <a:stretch>
+            <a:fillRect/>
+          </a:stretch>
+        </p:blipFill>
+        <p:spPr>
+          <a:xfrm>
+            <a:off x="10698480" y="292608"/>
+            <a:ext cx="960120" cy="110013"/>
+          </a:xfrm>
+          <a:prstGeom prst="rect">
+            <a:avLst/>
+          </a:prstGeom>
+        </p:spPr>
+      </p:pic>
     </p:spTree>
   </p:cSld>
   <p:clrMapOvr>
@@ -6898,7 +6970,7 @@
             <a:r>
               <a:rPr sz="2300" b="0" i="0">
                 <a:solidFill>
-                  <a:srgbClr val="051C2C"/>
+                  <a:srgbClr val="000000"/>
                 </a:solidFill>
                 <a:latin typeface="Georgia"/>
               </a:rPr>
@@ -7157,6 +7229,30 @@
           </a:p>
         </p:txBody>
       </p:sp>
+      <p:pic>
+        <p:nvPicPr>
+          <p:cNvPr id="9" name="Picture 8" descr="salomon_wordmark_black.png"/>
+          <p:cNvPicPr>
+            <a:picLocks noChangeAspect="1"/>
+          </p:cNvPicPr>
+          <p:nvPr/>
+        </p:nvPicPr>
+        <p:blipFill>
+          <a:blip r:embed="rId3"/>
+          <a:stretch>
+            <a:fillRect/>
+          </a:stretch>
+        </p:blipFill>
+        <p:spPr>
+          <a:xfrm>
+            <a:off x="10698480" y="292608"/>
+            <a:ext cx="960120" cy="110013"/>
+          </a:xfrm>
+          <a:prstGeom prst="rect">
+            <a:avLst/>
+          </a:prstGeom>
+        </p:spPr>
+      </p:pic>
     </p:spTree>
   </p:cSld>
   <p:clrMapOvr>
@@ -7190,7 +7286,7 @@
             <a:avLst/>
           </a:prstGeom>
           <a:solidFill>
-            <a:srgbClr val="051C2C"/>
+            <a:srgbClr val="000000"/>
           </a:solidFill>
           <a:ln>
             <a:noFill/>
@@ -7245,7 +7341,7 @@
             <a:r>
               <a:rPr sz="1100" b="1" i="0">
                 <a:solidFill>
-                  <a:srgbClr val="00A9F4"/>
+                  <a:srgbClr val="DA291C"/>
                 </a:solidFill>
                 <a:latin typeface="Arial"/>
               </a:rPr>
@@ -7315,7 +7411,7 @@
             <a:r>
               <a:rPr sz="2000" b="1" i="0">
                 <a:solidFill>
-                  <a:srgbClr val="00A9F4"/>
+                  <a:srgbClr val="DA291C"/>
                 </a:solidFill>
                 <a:latin typeface="Arial"/>
               </a:rPr>
@@ -7363,7 +7459,7 @@
             <a:r>
               <a:rPr sz="1150" b="0" i="0">
                 <a:solidFill>
-                  <a:srgbClr val="C9D4DC"/>
+                  <a:srgbClr val="F1C7C2"/>
                 </a:solidFill>
                 <a:latin typeface="Arial"/>
               </a:rPr>
@@ -7398,7 +7494,7 @@
             <a:r>
               <a:rPr sz="2000" b="1" i="0">
                 <a:solidFill>
-                  <a:srgbClr val="00A9F4"/>
+                  <a:srgbClr val="DA291C"/>
                 </a:solidFill>
                 <a:latin typeface="Arial"/>
               </a:rPr>
@@ -7446,7 +7542,7 @@
             <a:r>
               <a:rPr sz="1150" b="0" i="0">
                 <a:solidFill>
-                  <a:srgbClr val="C9D4DC"/>
+                  <a:srgbClr val="F1C7C2"/>
                 </a:solidFill>
                 <a:latin typeface="Arial"/>
               </a:rPr>
@@ -7481,7 +7577,7 @@
             <a:r>
               <a:rPr sz="2000" b="1" i="0">
                 <a:solidFill>
-                  <a:srgbClr val="00A9F4"/>
+                  <a:srgbClr val="DA291C"/>
                 </a:solidFill>
                 <a:latin typeface="Arial"/>
               </a:rPr>
@@ -7529,7 +7625,7 @@
             <a:r>
               <a:rPr sz="1150" b="0" i="0">
                 <a:solidFill>
-                  <a:srgbClr val="C9D4DC"/>
+                  <a:srgbClr val="F1C7C2"/>
                 </a:solidFill>
                 <a:latin typeface="Arial"/>
               </a:rPr>
@@ -7564,7 +7660,7 @@
             <a:r>
               <a:rPr sz="2000" b="1" i="0">
                 <a:solidFill>
-                  <a:srgbClr val="00A9F4"/>
+                  <a:srgbClr val="DA291C"/>
                 </a:solidFill>
                 <a:latin typeface="Arial"/>
               </a:rPr>
@@ -7612,7 +7708,7 @@
             <a:r>
               <a:rPr sz="1150" b="0" i="0">
                 <a:solidFill>
-                  <a:srgbClr val="C9D4DC"/>
+                  <a:srgbClr val="F1C7C2"/>
                 </a:solidFill>
                 <a:latin typeface="Arial"/>
               </a:rPr>
@@ -7647,7 +7743,7 @@
             <a:r>
               <a:rPr sz="2000" b="1" i="0">
                 <a:solidFill>
-                  <a:srgbClr val="00A9F4"/>
+                  <a:srgbClr val="DA291C"/>
                 </a:solidFill>
                 <a:latin typeface="Arial"/>
               </a:rPr>
@@ -7695,7 +7791,7 @@
             <a:r>
               <a:rPr sz="1150" b="0" i="0">
                 <a:solidFill>
-                  <a:srgbClr val="C9D4DC"/>
+                  <a:srgbClr val="F1C7C2"/>
                 </a:solidFill>
                 <a:latin typeface="Arial"/>
               </a:rPr>
@@ -7730,7 +7826,7 @@
             <a:r>
               <a:rPr sz="2000" b="1" i="0">
                 <a:solidFill>
-                  <a:srgbClr val="00A9F4"/>
+                  <a:srgbClr val="DA291C"/>
                 </a:solidFill>
                 <a:latin typeface="Arial"/>
               </a:rPr>
@@ -7778,7 +7874,7 @@
             <a:r>
               <a:rPr sz="1150" b="0" i="0">
                 <a:solidFill>
-                  <a:srgbClr val="C9D4DC"/>
+                  <a:srgbClr val="F1C7C2"/>
                 </a:solidFill>
                 <a:latin typeface="Arial"/>
               </a:rPr>
@@ -7822,6 +7918,30 @@
           </a:p>
         </p:txBody>
       </p:sp>
+      <p:pic>
+        <p:nvPicPr>
+          <p:cNvPr id="18" name="Picture 17" descr="salomon_wordmark_black.png"/>
+          <p:cNvPicPr>
+            <a:picLocks noChangeAspect="1"/>
+          </p:cNvPicPr>
+          <p:nvPr/>
+        </p:nvPicPr>
+        <p:blipFill>
+          <a:blip r:embed="rId2"/>
+          <a:stretch>
+            <a:fillRect/>
+          </a:stretch>
+        </p:blipFill>
+        <p:spPr>
+          <a:xfrm>
+            <a:off x="10698480" y="292608"/>
+            <a:ext cx="960120" cy="110013"/>
+          </a:xfrm>
+          <a:prstGeom prst="rect">
+            <a:avLst/>
+          </a:prstGeom>
+        </p:spPr>
+      </p:pic>
     </p:spTree>
   </p:cSld>
   <p:clrMapOvr>
@@ -7901,7 +8021,7 @@
             <a:r>
               <a:rPr sz="2300" b="0" i="0">
                 <a:solidFill>
-                  <a:srgbClr val="051C2C"/>
+                  <a:srgbClr val="000000"/>
                 </a:solidFill>
                 <a:latin typeface="Georgia"/>
               </a:rPr>
@@ -8015,7 +8135,7 @@
             <a:r>
               <a:rPr sz="4000" b="1" i="0">
                 <a:solidFill>
-                  <a:srgbClr val="2251FF"/>
+                  <a:srgbClr val="DA291C"/>
                 </a:solidFill>
                 <a:latin typeface="Arial"/>
               </a:rPr>
@@ -8212,7 +8332,7 @@
             <a:r>
               <a:rPr sz="4000" b="1" i="0">
                 <a:solidFill>
-                  <a:srgbClr val="2251FF"/>
+                  <a:srgbClr val="DA291C"/>
                 </a:solidFill>
                 <a:latin typeface="Arial"/>
               </a:rPr>
@@ -8409,7 +8529,7 @@
             <a:r>
               <a:rPr sz="4000" b="1" i="0">
                 <a:solidFill>
-                  <a:srgbClr val="2251FF"/>
+                  <a:srgbClr val="DA291C"/>
                 </a:solidFill>
                 <a:latin typeface="Arial"/>
               </a:rPr>
@@ -8606,7 +8726,7 @@
             <a:r>
               <a:rPr sz="4000" b="1" i="0">
                 <a:solidFill>
-                  <a:srgbClr val="2251FF"/>
+                  <a:srgbClr val="DA291C"/>
                 </a:solidFill>
                 <a:latin typeface="Arial"/>
               </a:rPr>
@@ -8713,7 +8833,7 @@
             <a:avLst/>
           </a:prstGeom>
           <a:solidFill>
-            <a:srgbClr val="051C2C"/>
+            <a:srgbClr val="000000"/>
           </a:solidFill>
           <a:ln>
             <a:noFill/>
@@ -8873,6 +8993,30 @@
           </a:p>
         </p:txBody>
       </p:sp>
+      <p:pic>
+        <p:nvPicPr>
+          <p:cNvPr id="28" name="Picture 27" descr="salomon_wordmark_black.png"/>
+          <p:cNvPicPr>
+            <a:picLocks noChangeAspect="1"/>
+          </p:cNvPicPr>
+          <p:nvPr/>
+        </p:nvPicPr>
+        <p:blipFill>
+          <a:blip r:embed="rId2"/>
+          <a:stretch>
+            <a:fillRect/>
+          </a:stretch>
+        </p:blipFill>
+        <p:spPr>
+          <a:xfrm>
+            <a:off x="10698480" y="292608"/>
+            <a:ext cx="960120" cy="110013"/>
+          </a:xfrm>
+          <a:prstGeom prst="rect">
+            <a:avLst/>
+          </a:prstGeom>
+        </p:spPr>
+      </p:pic>
     </p:spTree>
   </p:cSld>
   <p:clrMapOvr>
@@ -8952,7 +9096,7 @@
             <a:r>
               <a:rPr sz="2300" b="0" i="0">
                 <a:solidFill>
-                  <a:srgbClr val="051C2C"/>
+                  <a:srgbClr val="000000"/>
                 </a:solidFill>
                 <a:latin typeface="Georgia"/>
               </a:rPr>
@@ -9423,7 +9567,7 @@
             <a:r>
               <a:rPr sz="1100" b="1" i="0">
                 <a:solidFill>
-                  <a:srgbClr val="051C2C"/>
+                  <a:srgbClr val="000000"/>
                 </a:solidFill>
                 <a:latin typeface="Arial"/>
               </a:rPr>
@@ -9485,7 +9629,7 @@
             <a:avLst/>
           </a:prstGeom>
           <a:solidFill>
-            <a:srgbClr val="051C2C"/>
+            <a:srgbClr val="000000"/>
           </a:solidFill>
           <a:ln>
             <a:noFill/>
@@ -9566,7 +9710,7 @@
             <a:r>
               <a:rPr sz="1100" b="0" i="0">
                 <a:solidFill>
-                  <a:srgbClr val="00A9F4"/>
+                  <a:srgbClr val="DA291C"/>
                 </a:solidFill>
                 <a:latin typeface="Arial"/>
               </a:rPr>
@@ -9671,7 +9815,7 @@
             <a:r>
               <a:rPr sz="1100" b="1" i="0">
                 <a:solidFill>
-                  <a:srgbClr val="051C2C"/>
+                  <a:srgbClr val="000000"/>
                 </a:solidFill>
                 <a:latin typeface="Arial"/>
               </a:rPr>
@@ -9788,6 +9932,30 @@
           </a:p>
         </p:txBody>
       </p:sp>
+      <p:pic>
+        <p:nvPicPr>
+          <p:cNvPr id="19" name="Picture 18" descr="salomon_wordmark_black.png"/>
+          <p:cNvPicPr>
+            <a:picLocks noChangeAspect="1"/>
+          </p:cNvPicPr>
+          <p:nvPr/>
+        </p:nvPicPr>
+        <p:blipFill>
+          <a:blip r:embed="rId2"/>
+          <a:stretch>
+            <a:fillRect/>
+          </a:stretch>
+        </p:blipFill>
+        <p:spPr>
+          <a:xfrm>
+            <a:off x="10698480" y="292608"/>
+            <a:ext cx="960120" cy="110013"/>
+          </a:xfrm>
+          <a:prstGeom prst="rect">
+            <a:avLst/>
+          </a:prstGeom>
+        </p:spPr>
+      </p:pic>
     </p:spTree>
   </p:cSld>
   <p:clrMapOvr>
@@ -9867,7 +10035,7 @@
             <a:r>
               <a:rPr sz="2300" b="0" i="0">
                 <a:solidFill>
-                  <a:srgbClr val="051C2C"/>
+                  <a:srgbClr val="000000"/>
                 </a:solidFill>
                 <a:latin typeface="Georgia"/>
               </a:rPr>
@@ -9946,7 +10114,7 @@
             <a:r>
               <a:rPr sz="1150" b="1" i="0">
                 <a:solidFill>
-                  <a:srgbClr val="051C2C"/>
+                  <a:srgbClr val="000000"/>
                 </a:solidFill>
                 <a:latin typeface="Arial"/>
               </a:rPr>
@@ -9955,7 +10123,7 @@
             <a:r>
               <a:rPr sz="1000" b="1" i="0">
                 <a:solidFill>
-                  <a:srgbClr val="2251FF"/>
+                  <a:srgbClr val="DA291C"/>
                 </a:solidFill>
                 <a:latin typeface="Arial"/>
               </a:rPr>
@@ -10073,7 +10241,7 @@
             <a:r>
               <a:rPr sz="1150" b="1" i="0">
                 <a:solidFill>
-                  <a:srgbClr val="051C2C"/>
+                  <a:srgbClr val="000000"/>
                 </a:solidFill>
                 <a:latin typeface="Arial"/>
               </a:rPr>
@@ -10082,7 +10250,7 @@
             <a:r>
               <a:rPr sz="1000" b="1" i="0">
                 <a:solidFill>
-                  <a:srgbClr val="2251FF"/>
+                  <a:srgbClr val="DA291C"/>
                 </a:solidFill>
                 <a:latin typeface="Arial"/>
               </a:rPr>
@@ -10200,7 +10368,7 @@
             <a:r>
               <a:rPr sz="1150" b="1" i="0">
                 <a:solidFill>
-                  <a:srgbClr val="051C2C"/>
+                  <a:srgbClr val="000000"/>
                 </a:solidFill>
                 <a:latin typeface="Arial"/>
               </a:rPr>
@@ -10327,7 +10495,7 @@
             <a:r>
               <a:rPr sz="1150" b="1" i="0">
                 <a:solidFill>
-                  <a:srgbClr val="051C2C"/>
+                  <a:srgbClr val="000000"/>
                 </a:solidFill>
                 <a:latin typeface="Arial"/>
               </a:rPr>
@@ -10454,6 +10622,30 @@
           </a:p>
         </p:txBody>
       </p:sp>
+      <p:pic>
+        <p:nvPicPr>
+          <p:cNvPr id="18" name="Picture 17" descr="salomon_wordmark_black.png"/>
+          <p:cNvPicPr>
+            <a:picLocks noChangeAspect="1"/>
+          </p:cNvPicPr>
+          <p:nvPr/>
+        </p:nvPicPr>
+        <p:blipFill>
+          <a:blip r:embed="rId2"/>
+          <a:stretch>
+            <a:fillRect/>
+          </a:stretch>
+        </p:blipFill>
+        <p:spPr>
+          <a:xfrm>
+            <a:off x="10698480" y="292608"/>
+            <a:ext cx="960120" cy="110013"/>
+          </a:xfrm>
+          <a:prstGeom prst="rect">
+            <a:avLst/>
+          </a:prstGeom>
+        </p:spPr>
+      </p:pic>
     </p:spTree>
   </p:cSld>
   <p:clrMapOvr>
@@ -10533,7 +10725,7 @@
             <a:r>
               <a:rPr sz="2300" b="0" i="0">
                 <a:solidFill>
-                  <a:srgbClr val="051C2C"/>
+                  <a:srgbClr val="000000"/>
                 </a:solidFill>
                 <a:latin typeface="Georgia"/>
               </a:rPr>
@@ -10576,7 +10768,7 @@
           </a:prstGeom>
           <a:ln w="12700">
             <a:solidFill>
-              <a:srgbClr val="051C2C"/>
+              <a:srgbClr val="000000"/>
             </a:solidFill>
             <a:prstDash val="dash"/>
           </a:ln>
@@ -10622,7 +10814,7 @@
             <a:r>
               <a:rPr sz="950" b="1" i="0">
                 <a:solidFill>
-                  <a:srgbClr val="051C2C"/>
+                  <a:srgbClr val="000000"/>
                 </a:solidFill>
                 <a:latin typeface="Arial"/>
               </a:rPr>
@@ -10778,7 +10970,7 @@
             <a:r>
               <a:rPr sz="2200" b="1" i="0">
                 <a:solidFill>
-                  <a:srgbClr val="2251FF"/>
+                  <a:srgbClr val="DA291C"/>
                 </a:solidFill>
                 <a:latin typeface="Arial"/>
               </a:rPr>
@@ -10876,6 +11068,30 @@
           </a:p>
         </p:txBody>
       </p:sp>
+      <p:pic>
+        <p:nvPicPr>
+          <p:cNvPr id="10" name="Picture 9" descr="salomon_wordmark_black.png"/>
+          <p:cNvPicPr>
+            <a:picLocks noChangeAspect="1"/>
+          </p:cNvPicPr>
+          <p:nvPr/>
+        </p:nvPicPr>
+        <p:blipFill>
+          <a:blip r:embed="rId3"/>
+          <a:stretch>
+            <a:fillRect/>
+          </a:stretch>
+        </p:blipFill>
+        <p:spPr>
+          <a:xfrm>
+            <a:off x="10698480" y="292608"/>
+            <a:ext cx="960120" cy="110013"/>
+          </a:xfrm>
+          <a:prstGeom prst="rect">
+            <a:avLst/>
+          </a:prstGeom>
+        </p:spPr>
+      </p:pic>
     </p:spTree>
   </p:cSld>
   <p:clrMapOvr>
@@ -10955,7 +11171,7 @@
             <a:r>
               <a:rPr sz="2300" b="0" i="0">
                 <a:solidFill>
-                  <a:srgbClr val="051C2C"/>
+                  <a:srgbClr val="000000"/>
                 </a:solidFill>
                 <a:latin typeface="Georgia"/>
               </a:rPr>
@@ -11170,6 +11386,30 @@
           </a:p>
         </p:txBody>
       </p:sp>
+      <p:pic>
+        <p:nvPicPr>
+          <p:cNvPr id="8" name="Picture 7" descr="salomon_wordmark_black.png"/>
+          <p:cNvPicPr>
+            <a:picLocks noChangeAspect="1"/>
+          </p:cNvPicPr>
+          <p:nvPr/>
+        </p:nvPicPr>
+        <p:blipFill>
+          <a:blip r:embed="rId3"/>
+          <a:stretch>
+            <a:fillRect/>
+          </a:stretch>
+        </p:blipFill>
+        <p:spPr>
+          <a:xfrm>
+            <a:off x="10698480" y="292608"/>
+            <a:ext cx="960120" cy="110013"/>
+          </a:xfrm>
+          <a:prstGeom prst="rect">
+            <a:avLst/>
+          </a:prstGeom>
+        </p:spPr>
+      </p:pic>
     </p:spTree>
   </p:cSld>
   <p:clrMapOvr>
@@ -11249,7 +11489,7 @@
             <a:r>
               <a:rPr sz="2300" b="0" i="0">
                 <a:solidFill>
-                  <a:srgbClr val="051C2C"/>
+                  <a:srgbClr val="000000"/>
                 </a:solidFill>
                 <a:latin typeface="Georgia"/>
               </a:rPr>
@@ -11341,7 +11581,7 @@
             <a:r>
               <a:rPr sz="2600" b="1" i="0">
                 <a:solidFill>
-                  <a:srgbClr val="051C2C"/>
+                  <a:srgbClr val="000000"/>
                 </a:solidFill>
                 <a:latin typeface="Arial"/>
               </a:rPr>
@@ -11396,7 +11636,7 @@
             <a:r>
               <a:rPr sz="1100" b="1" i="0">
                 <a:solidFill>
-                  <a:srgbClr val="2251FF"/>
+                  <a:srgbClr val="DA291C"/>
                 </a:solidFill>
                 <a:latin typeface="Arial"/>
               </a:rPr>
@@ -11647,7 +11887,7 @@
             <a:r>
               <a:rPr sz="2100" b="1" i="0">
                 <a:solidFill>
-                  <a:srgbClr val="2251FF"/>
+                  <a:srgbClr val="DA291C"/>
                 </a:solidFill>
                 <a:latin typeface="Arial"/>
               </a:rPr>
@@ -11977,6 +12217,30 @@
           </a:p>
         </p:txBody>
       </p:sp>
+      <p:pic>
+        <p:nvPicPr>
+          <p:cNvPr id="19" name="Picture 18" descr="salomon_wordmark_black.png"/>
+          <p:cNvPicPr>
+            <a:picLocks noChangeAspect="1"/>
+          </p:cNvPicPr>
+          <p:nvPr/>
+        </p:nvPicPr>
+        <p:blipFill>
+          <a:blip r:embed="rId4"/>
+          <a:stretch>
+            <a:fillRect/>
+          </a:stretch>
+        </p:blipFill>
+        <p:spPr>
+          <a:xfrm>
+            <a:off x="10698480" y="292608"/>
+            <a:ext cx="960120" cy="110013"/>
+          </a:xfrm>
+          <a:prstGeom prst="rect">
+            <a:avLst/>
+          </a:prstGeom>
+        </p:spPr>
+      </p:pic>
     </p:spTree>
   </p:cSld>
   <p:clrMapOvr>
@@ -12056,7 +12320,7 @@
             <a:r>
               <a:rPr sz="2300" b="0" i="0">
                 <a:solidFill>
-                  <a:srgbClr val="051C2C"/>
+                  <a:srgbClr val="000000"/>
                 </a:solidFill>
                 <a:latin typeface="Georgia"/>
               </a:rPr>
@@ -12218,7 +12482,7 @@
             <a:r>
               <a:rPr sz="3400" b="1" i="0">
                 <a:solidFill>
-                  <a:srgbClr val="2251FF"/>
+                  <a:srgbClr val="DA291C"/>
                 </a:solidFill>
                 <a:latin typeface="Arial"/>
               </a:rPr>
@@ -12439,6 +12703,30 @@
           </a:p>
         </p:txBody>
       </p:sp>
+      <p:pic>
+        <p:nvPicPr>
+          <p:cNvPr id="12" name="Picture 11" descr="salomon_wordmark_black.png"/>
+          <p:cNvPicPr>
+            <a:picLocks noChangeAspect="1"/>
+          </p:cNvPicPr>
+          <p:nvPr/>
+        </p:nvPicPr>
+        <p:blipFill>
+          <a:blip r:embed="rId3"/>
+          <a:stretch>
+            <a:fillRect/>
+          </a:stretch>
+        </p:blipFill>
+        <p:spPr>
+          <a:xfrm>
+            <a:off x="10698480" y="292608"/>
+            <a:ext cx="960120" cy="110013"/>
+          </a:xfrm>
+          <a:prstGeom prst="rect">
+            <a:avLst/>
+          </a:prstGeom>
+        </p:spPr>
+      </p:pic>
     </p:spTree>
   </p:cSld>
   <p:clrMapOvr>
@@ -12518,7 +12806,7 @@
             <a:r>
               <a:rPr sz="2300" b="0" i="0">
                 <a:solidFill>
-                  <a:srgbClr val="051C2C"/>
+                  <a:srgbClr val="000000"/>
                 </a:solidFill>
                 <a:latin typeface="Georgia"/>
               </a:rPr>
@@ -12862,6 +13150,30 @@
           </a:p>
         </p:txBody>
       </p:sp>
+      <p:pic>
+        <p:nvPicPr>
+          <p:cNvPr id="12" name="Picture 11" descr="salomon_wordmark_black.png"/>
+          <p:cNvPicPr>
+            <a:picLocks noChangeAspect="1"/>
+          </p:cNvPicPr>
+          <p:nvPr/>
+        </p:nvPicPr>
+        <p:blipFill>
+          <a:blip r:embed="rId3"/>
+          <a:stretch>
+            <a:fillRect/>
+          </a:stretch>
+        </p:blipFill>
+        <p:spPr>
+          <a:xfrm>
+            <a:off x="10698480" y="292608"/>
+            <a:ext cx="960120" cy="110013"/>
+          </a:xfrm>
+          <a:prstGeom prst="rect">
+            <a:avLst/>
+          </a:prstGeom>
+        </p:spPr>
+      </p:pic>
     </p:spTree>
   </p:cSld>
   <p:clrMapOvr>
@@ -12881,13 +13193,13 @@
         <a:sysClr val="window" lastClr="FFFFFF"/>
       </a:lt1>
       <a:dk2>
-        <a:srgbClr val="1F497D"/>
+        <a:srgbClr val="000000"/>
       </a:dk2>
       <a:lt2>
         <a:srgbClr val="EEECE1"/>
       </a:lt2>
       <a:accent1>
-        <a:srgbClr val="4F81BD"/>
+        <a:srgbClr val="DA291C"/>
       </a:accent1>
       <a:accent2>
         <a:srgbClr val="C0504D"/>

</xml_diff>